<commit_message>
fix: Split bonus matematico into 2 slides with proper spacing
- Slide 8a: Weight Decay (sin vs con), formulas grandes y legibles
- Slide 8b: Dropout + Loss total con L2
- Each formula in its own card with explanation text above
- No more overlapping elements

https://claude.ai/code/session_01W42GUpoj5yPrRQoHtoBaF5
</commit_message>
<xml_diff>
--- a/Grupo7_La_Memoria_de_Pez.pptx
+++ b/Grupo7_La_Memoria_de_Pez.pptx
@@ -14,6 +14,7 @@
     <p:sldId id="262" r:id="rId13"/>
     <p:sldId id="263" r:id="rId14"/>
     <p:sldId id="264" r:id="rId15"/>
+    <p:sldId id="265" r:id="rId16"/>
   </p:sldIdLst>
   <p:sldSz cx="12191695" cy="6858000" type="screen4x3"/>
   <p:notesSz cx="6858000" cy="9144000"/>
@@ -3359,6 +3360,607 @@
             </a:pPr>
             <a:r>
               <a:t>Escuela de Posgrado  |  Modelos de Deep Learning</a:t>
+            </a:r>
+          </a:p>
+        </p:txBody>
+      </p:sp>
+    </p:spTree>
+  </p:cSld>
+  <p:clrMapOvr>
+    <a:masterClrMapping/>
+  </p:clrMapOvr>
+</p:sld>
+</file>
+
+<file path=ppt/slides/slide10.xml><?xml version="1.0" encoding="utf-8"?>
+<p:sld xmlns:a="http://schemas.openxmlformats.org/drawingml/2006/main" xmlns:p="http://schemas.openxmlformats.org/presentationml/2006/main" xmlns:r="http://schemas.openxmlformats.org/officeDocument/2006/relationships">
+  <p:cSld>
+    <p:bg>
+      <p:bgPr>
+        <a:solidFill>
+          <a:srgbClr val="14141E"/>
+        </a:solidFill>
+        <a:effectLst/>
+      </p:bgPr>
+    </p:bg>
+    <p:spTree>
+      <p:nvGrpSpPr>
+        <p:cNvPr id="1" name=""/>
+        <p:cNvGrpSpPr/>
+        <p:nvPr/>
+      </p:nvGrpSpPr>
+      <p:grpSpPr/>
+      <p:sp>
+        <p:nvSpPr>
+          <p:cNvPr id="2" name="TextBox 1"/>
+          <p:cNvSpPr txBox="1"/>
+          <p:nvPr/>
+        </p:nvSpPr>
+        <p:spPr>
+          <a:xfrm>
+            <a:off x="1097280" y="457200"/>
+            <a:ext cx="9144000" cy="640080"/>
+          </a:xfrm>
+          <a:prstGeom prst="rect">
+            <a:avLst/>
+          </a:prstGeom>
+          <a:noFill/>
+        </p:spPr>
+        <p:txBody>
+          <a:bodyPr wrap="square">
+            <a:spAutoFit/>
+          </a:bodyPr>
+          <a:lstStyle/>
+          <a:p>
+            <a:pPr algn="l">
+              <a:defRPr sz="4200" b="1">
+                <a:solidFill>
+                  <a:srgbClr val="FFFFFF"/>
+                </a:solidFill>
+                <a:latin typeface="Calibri"/>
+              </a:defRPr>
+            </a:pPr>
+            <a:r>
+              <a:t>Conclusiones</a:t>
+            </a:r>
+          </a:p>
+        </p:txBody>
+      </p:sp>
+      <p:sp>
+        <p:nvSpPr>
+          <p:cNvPr id="3" name="Rectangle 2"/>
+          <p:cNvSpPr/>
+          <p:nvPr/>
+        </p:nvSpPr>
+        <p:spPr>
+          <a:xfrm>
+            <a:off x="1097280" y="1051560"/>
+            <a:ext cx="2286000" cy="38100"/>
+          </a:xfrm>
+          <a:prstGeom prst="rect">
+            <a:avLst/>
+          </a:prstGeom>
+          <a:solidFill>
+            <a:srgbClr val="1A73E8"/>
+          </a:solidFill>
+          <a:ln>
+            <a:noFill/>
+          </a:ln>
+        </p:spPr>
+        <p:style>
+          <a:lnRef idx="1">
+            <a:schemeClr val="accent1"/>
+          </a:lnRef>
+          <a:fillRef idx="3">
+            <a:schemeClr val="accent1"/>
+          </a:fillRef>
+          <a:effectRef idx="2">
+            <a:schemeClr val="accent1"/>
+          </a:effectRef>
+          <a:fontRef idx="minor">
+            <a:schemeClr val="lt1"/>
+          </a:fontRef>
+        </p:style>
+        <p:txBody>
+          <a:bodyPr rtlCol="0" anchor="ctr"/>
+          <a:lstStyle/>
+          <a:p>
+            <a:pPr algn="ctr"/>
+          </a:p>
+        </p:txBody>
+      </p:sp>
+      <p:sp>
+        <p:nvSpPr>
+          <p:cNvPr id="4" name="Oval 3"/>
+          <p:cNvSpPr/>
+          <p:nvPr/>
+        </p:nvSpPr>
+        <p:spPr>
+          <a:xfrm>
+            <a:off x="1097280" y="1600200"/>
+            <a:ext cx="152400" cy="152400"/>
+          </a:xfrm>
+          <a:prstGeom prst="ellipse">
+            <a:avLst/>
+          </a:prstGeom>
+          <a:solidFill>
+            <a:srgbClr val="1A73E8"/>
+          </a:solidFill>
+          <a:ln>
+            <a:noFill/>
+          </a:ln>
+        </p:spPr>
+        <p:style>
+          <a:lnRef idx="1">
+            <a:schemeClr val="accent1"/>
+          </a:lnRef>
+          <a:fillRef idx="3">
+            <a:schemeClr val="accent1"/>
+          </a:fillRef>
+          <a:effectRef idx="2">
+            <a:schemeClr val="accent1"/>
+          </a:effectRef>
+          <a:fontRef idx="minor">
+            <a:schemeClr val="lt1"/>
+          </a:fontRef>
+        </p:style>
+        <p:txBody>
+          <a:bodyPr rtlCol="0" anchor="ctr"/>
+          <a:lstStyle/>
+          <a:p>
+            <a:pPr algn="ctr"/>
+          </a:p>
+        </p:txBody>
+      </p:sp>
+      <p:sp>
+        <p:nvSpPr>
+          <p:cNvPr id="5" name="TextBox 4"/>
+          <p:cNvSpPr txBox="1"/>
+          <p:nvPr/>
+        </p:nvSpPr>
+        <p:spPr>
+          <a:xfrm>
+            <a:off x="1463040" y="1417320"/>
+            <a:ext cx="2743200" cy="365760"/>
+          </a:xfrm>
+          <a:prstGeom prst="rect">
+            <a:avLst/>
+          </a:prstGeom>
+          <a:noFill/>
+        </p:spPr>
+        <p:txBody>
+          <a:bodyPr wrap="square">
+            <a:spAutoFit/>
+          </a:bodyPr>
+          <a:lstStyle/>
+          <a:p>
+            <a:pPr algn="l">
+              <a:defRPr sz="2000" b="1">
+                <a:solidFill>
+                  <a:srgbClr val="1A73E8"/>
+                </a:solidFill>
+                <a:latin typeface="Calibri"/>
+              </a:defRPr>
+            </a:pPr>
+            <a:r>
+              <a:t>Diagnostico</a:t>
+            </a:r>
+          </a:p>
+        </p:txBody>
+      </p:sp>
+      <p:sp>
+        <p:nvSpPr>
+          <p:cNvPr id="6" name="TextBox 5"/>
+          <p:cNvSpPr txBox="1"/>
+          <p:nvPr/>
+        </p:nvSpPr>
+        <p:spPr>
+          <a:xfrm>
+            <a:off x="1463040" y="1783080"/>
+            <a:ext cx="9144000" cy="457200"/>
+          </a:xfrm>
+          <a:prstGeom prst="rect">
+            <a:avLst/>
+          </a:prstGeom>
+          <a:noFill/>
+        </p:spPr>
+        <p:txBody>
+          <a:bodyPr wrap="square">
+            <a:spAutoFit/>
+          </a:bodyPr>
+          <a:lstStyle/>
+          <a:p>
+            <a:pPr algn="l">
+              <a:defRPr sz="1600" b="0">
+                <a:solidFill>
+                  <a:srgbClr val="E8E8E8"/>
+                </a:solidFill>
+                <a:latin typeface="Calibri"/>
+              </a:defRPr>
+            </a:pPr>
+            <a:r>
+              <a:t>El modelo memorizaba el dataset. Train ~100%, Test ~65-75%. Overfitting violento por falta de regularizacion.</a:t>
+            </a:r>
+          </a:p>
+        </p:txBody>
+      </p:sp>
+      <p:sp>
+        <p:nvSpPr>
+          <p:cNvPr id="7" name="Oval 6"/>
+          <p:cNvSpPr/>
+          <p:nvPr/>
+        </p:nvSpPr>
+        <p:spPr>
+          <a:xfrm>
+            <a:off x="1097280" y="2651760"/>
+            <a:ext cx="152400" cy="152400"/>
+          </a:xfrm>
+          <a:prstGeom prst="ellipse">
+            <a:avLst/>
+          </a:prstGeom>
+          <a:solidFill>
+            <a:srgbClr val="1A73E8"/>
+          </a:solidFill>
+          <a:ln>
+            <a:noFill/>
+          </a:ln>
+        </p:spPr>
+        <p:style>
+          <a:lnRef idx="1">
+            <a:schemeClr val="accent1"/>
+          </a:lnRef>
+          <a:fillRef idx="3">
+            <a:schemeClr val="accent1"/>
+          </a:fillRef>
+          <a:effectRef idx="2">
+            <a:schemeClr val="accent1"/>
+          </a:effectRef>
+          <a:fontRef idx="minor">
+            <a:schemeClr val="lt1"/>
+          </a:fontRef>
+        </p:style>
+        <p:txBody>
+          <a:bodyPr rtlCol="0" anchor="ctr"/>
+          <a:lstStyle/>
+          <a:p>
+            <a:pPr algn="ctr"/>
+          </a:p>
+        </p:txBody>
+      </p:sp>
+      <p:sp>
+        <p:nvSpPr>
+          <p:cNvPr id="8" name="TextBox 7"/>
+          <p:cNvSpPr txBox="1"/>
+          <p:nvPr/>
+        </p:nvSpPr>
+        <p:spPr>
+          <a:xfrm>
+            <a:off x="1463040" y="2468880"/>
+            <a:ext cx="2743200" cy="365760"/>
+          </a:xfrm>
+          <a:prstGeom prst="rect">
+            <a:avLst/>
+          </a:prstGeom>
+          <a:noFill/>
+        </p:spPr>
+        <p:txBody>
+          <a:bodyPr wrap="square">
+            <a:spAutoFit/>
+          </a:bodyPr>
+          <a:lstStyle/>
+          <a:p>
+            <a:pPr algn="l">
+              <a:defRPr sz="2000" b="1">
+                <a:solidFill>
+                  <a:srgbClr val="1A73E8"/>
+                </a:solidFill>
+                <a:latin typeface="Calibri"/>
+              </a:defRPr>
+            </a:pPr>
+            <a:r>
+              <a:t>Interruptor</a:t>
+            </a:r>
+          </a:p>
+        </p:txBody>
+      </p:sp>
+      <p:sp>
+        <p:nvSpPr>
+          <p:cNvPr id="9" name="TextBox 8"/>
+          <p:cNvSpPr txBox="1"/>
+          <p:nvPr/>
+        </p:nvSpPr>
+        <p:spPr>
+          <a:xfrm>
+            <a:off x="1463040" y="2834640"/>
+            <a:ext cx="9144000" cy="457200"/>
+          </a:xfrm>
+          <a:prstGeom prst="rect">
+            <a:avLst/>
+          </a:prstGeom>
+          <a:noFill/>
+        </p:spPr>
+        <p:txBody>
+          <a:bodyPr wrap="square">
+            <a:spAutoFit/>
+          </a:bodyPr>
+          <a:lstStyle/>
+          <a:p>
+            <a:pPr algn="l">
+              <a:defRPr sz="1600" b="0">
+                <a:solidFill>
+                  <a:srgbClr val="E8E8E8"/>
+                </a:solidFill>
+                <a:latin typeface="Calibri"/>
+              </a:defRPr>
+            </a:pPr>
+            <a:r>
+              <a:t>Activamos Weight Decay (L2=0.01), Dropout (p=0.3) y redujimos la red de ~19K a ~300 parametros.</a:t>
+            </a:r>
+          </a:p>
+        </p:txBody>
+      </p:sp>
+      <p:sp>
+        <p:nvSpPr>
+          <p:cNvPr id="10" name="Oval 9"/>
+          <p:cNvSpPr/>
+          <p:nvPr/>
+        </p:nvSpPr>
+        <p:spPr>
+          <a:xfrm>
+            <a:off x="1097280" y="3703320"/>
+            <a:ext cx="152400" cy="152400"/>
+          </a:xfrm>
+          <a:prstGeom prst="ellipse">
+            <a:avLst/>
+          </a:prstGeom>
+          <a:solidFill>
+            <a:srgbClr val="1A73E8"/>
+          </a:solidFill>
+          <a:ln>
+            <a:noFill/>
+          </a:ln>
+        </p:spPr>
+        <p:style>
+          <a:lnRef idx="1">
+            <a:schemeClr val="accent1"/>
+          </a:lnRef>
+          <a:fillRef idx="3">
+            <a:schemeClr val="accent1"/>
+          </a:fillRef>
+          <a:effectRef idx="2">
+            <a:schemeClr val="accent1"/>
+          </a:effectRef>
+          <a:fontRef idx="minor">
+            <a:schemeClr val="lt1"/>
+          </a:fontRef>
+        </p:style>
+        <p:txBody>
+          <a:bodyPr rtlCol="0" anchor="ctr"/>
+          <a:lstStyle/>
+          <a:p>
+            <a:pPr algn="ctr"/>
+          </a:p>
+        </p:txBody>
+      </p:sp>
+      <p:sp>
+        <p:nvSpPr>
+          <p:cNvPr id="11" name="TextBox 10"/>
+          <p:cNvSpPr txBox="1"/>
+          <p:nvPr/>
+        </p:nvSpPr>
+        <p:spPr>
+          <a:xfrm>
+            <a:off x="1463040" y="3520440"/>
+            <a:ext cx="2743200" cy="365760"/>
+          </a:xfrm>
+          <a:prstGeom prst="rect">
+            <a:avLst/>
+          </a:prstGeom>
+          <a:noFill/>
+        </p:spPr>
+        <p:txBody>
+          <a:bodyPr wrap="square">
+            <a:spAutoFit/>
+          </a:bodyPr>
+          <a:lstStyle/>
+          <a:p>
+            <a:pPr algn="l">
+              <a:defRPr sz="2000" b="1">
+                <a:solidFill>
+                  <a:srgbClr val="1A73E8"/>
+                </a:solidFill>
+                <a:latin typeface="Calibri"/>
+              </a:defRPr>
+            </a:pPr>
+            <a:r>
+              <a:t>Resultado</a:t>
+            </a:r>
+          </a:p>
+        </p:txBody>
+      </p:sp>
+      <p:sp>
+        <p:nvSpPr>
+          <p:cNvPr id="12" name="TextBox 11"/>
+          <p:cNvSpPr txBox="1"/>
+          <p:nvPr/>
+        </p:nvSpPr>
+        <p:spPr>
+          <a:xfrm>
+            <a:off x="1463040" y="3886200"/>
+            <a:ext cx="9144000" cy="457200"/>
+          </a:xfrm>
+          <a:prstGeom prst="rect">
+            <a:avLst/>
+          </a:prstGeom>
+          <a:noFill/>
+        </p:spPr>
+        <p:txBody>
+          <a:bodyPr wrap="square">
+            <a:spAutoFit/>
+          </a:bodyPr>
+          <a:lstStyle/>
+          <a:p>
+            <a:pPr algn="l">
+              <a:defRPr sz="1600" b="0">
+                <a:solidFill>
+                  <a:srgbClr val="E8E8E8"/>
+                </a:solidFill>
+                <a:latin typeface="Calibri"/>
+              </a:defRPr>
+            </a:pPr>
+            <a:r>
+              <a:t>La brecha train-test se redujo de ~30% a menos del 7%. El modelo ahora generaliza.</a:t>
+            </a:r>
+          </a:p>
+        </p:txBody>
+      </p:sp>
+      <p:sp>
+        <p:nvSpPr>
+          <p:cNvPr id="13" name="Oval 12"/>
+          <p:cNvSpPr/>
+          <p:nvPr/>
+        </p:nvSpPr>
+        <p:spPr>
+          <a:xfrm>
+            <a:off x="1097280" y="4754880"/>
+            <a:ext cx="152400" cy="152400"/>
+          </a:xfrm>
+          <a:prstGeom prst="ellipse">
+            <a:avLst/>
+          </a:prstGeom>
+          <a:solidFill>
+            <a:srgbClr val="1A73E8"/>
+          </a:solidFill>
+          <a:ln>
+            <a:noFill/>
+          </a:ln>
+        </p:spPr>
+        <p:style>
+          <a:lnRef idx="1">
+            <a:schemeClr val="accent1"/>
+          </a:lnRef>
+          <a:fillRef idx="3">
+            <a:schemeClr val="accent1"/>
+          </a:fillRef>
+          <a:effectRef idx="2">
+            <a:schemeClr val="accent1"/>
+          </a:effectRef>
+          <a:fontRef idx="minor">
+            <a:schemeClr val="lt1"/>
+          </a:fontRef>
+        </p:style>
+        <p:txBody>
+          <a:bodyPr rtlCol="0" anchor="ctr"/>
+          <a:lstStyle/>
+          <a:p>
+            <a:pPr algn="ctr"/>
+          </a:p>
+        </p:txBody>
+      </p:sp>
+      <p:sp>
+        <p:nvSpPr>
+          <p:cNvPr id="14" name="TextBox 13"/>
+          <p:cNvSpPr txBox="1"/>
+          <p:nvPr/>
+        </p:nvSpPr>
+        <p:spPr>
+          <a:xfrm>
+            <a:off x="1463040" y="4572000"/>
+            <a:ext cx="2743200" cy="365760"/>
+          </a:xfrm>
+          <a:prstGeom prst="rect">
+            <a:avLst/>
+          </a:prstGeom>
+          <a:noFill/>
+        </p:spPr>
+        <p:txBody>
+          <a:bodyPr wrap="square">
+            <a:spAutoFit/>
+          </a:bodyPr>
+          <a:lstStyle/>
+          <a:p>
+            <a:pPr algn="l">
+              <a:defRPr sz="2000" b="1">
+                <a:solidFill>
+                  <a:srgbClr val="1A73E8"/>
+                </a:solidFill>
+                <a:latin typeface="Calibri"/>
+              </a:defRPr>
+            </a:pPr>
+            <a:r>
+              <a:t>HealthTech</a:t>
+            </a:r>
+          </a:p>
+        </p:txBody>
+      </p:sp>
+      <p:sp>
+        <p:nvSpPr>
+          <p:cNvPr id="15" name="TextBox 14"/>
+          <p:cNvSpPr txBox="1"/>
+          <p:nvPr/>
+        </p:nvSpPr>
+        <p:spPr>
+          <a:xfrm>
+            <a:off x="1463040" y="4937759"/>
+            <a:ext cx="9144000" cy="457200"/>
+          </a:xfrm>
+          <a:prstGeom prst="rect">
+            <a:avLst/>
+          </a:prstGeom>
+          <a:noFill/>
+        </p:spPr>
+        <p:txBody>
+          <a:bodyPr wrap="square">
+            <a:spAutoFit/>
+          </a:bodyPr>
+          <a:lstStyle/>
+          <a:p>
+            <a:pPr algn="l">
+              <a:defRPr sz="1600" b="0">
+                <a:solidFill>
+                  <a:srgbClr val="E8E8E8"/>
+                </a:solidFill>
+                <a:latin typeface="Calibri"/>
+              </a:defRPr>
+            </a:pPr>
+            <a:r>
+              <a:t>En medicina, un modelo con overfitting da diagnosticos falsos en pacientes nuevos. La regularizacion es esencial.</a:t>
+            </a:r>
+          </a:p>
+        </p:txBody>
+      </p:sp>
+      <p:sp>
+        <p:nvSpPr>
+          <p:cNvPr id="16" name="TextBox 15"/>
+          <p:cNvSpPr txBox="1"/>
+          <p:nvPr/>
+        </p:nvSpPr>
+        <p:spPr>
+          <a:xfrm>
+            <a:off x="1097280" y="5943600"/>
+            <a:ext cx="9966960" cy="365760"/>
+          </a:xfrm>
+          <a:prstGeom prst="rect">
+            <a:avLst/>
+          </a:prstGeom>
+          <a:noFill/>
+        </p:spPr>
+        <p:txBody>
+          <a:bodyPr wrap="square">
+            <a:spAutoFit/>
+          </a:bodyPr>
+          <a:lstStyle/>
+          <a:p>
+            <a:pPr algn="ctr">
+              <a:defRPr sz="1300" b="0">
+                <a:solidFill>
+                  <a:srgbClr val="909090"/>
+                </a:solidFill>
+                <a:latin typeface="Calibri"/>
+              </a:defRPr>
+            </a:pPr>
+            <a:r>
+              <a:t>Grupo 7  |  La Memoria de Pez  |  Bloque 3: Problemas de Estrategia</a:t>
             </a:r>
           </a:p>
         </p:txBody>
@@ -8218,7 +8820,7 @@
         </p:nvSpPr>
         <p:spPr>
           <a:xfrm>
-            <a:off x="1097280" y="1463040"/>
+            <a:off x="1097280" y="1280160"/>
             <a:ext cx="9144000" cy="365760"/>
           </a:xfrm>
           <a:prstGeom prst="rect">
@@ -8233,65 +8835,29 @@
           <a:lstStyle/>
           <a:p>
             <a:pPr algn="l">
-              <a:defRPr sz="1900" b="1">
-                <a:solidFill>
-                  <a:srgbClr val="2A2A2A"/>
-                </a:solidFill>
-                <a:latin typeface="Calibri"/>
-              </a:defRPr>
-            </a:pPr>
-            <a:r>
-              <a:t>Sin Weight Decay</a:t>
-            </a:r>
-          </a:p>
-        </p:txBody>
-      </p:sp>
-      <p:sp>
-        <p:nvSpPr>
-          <p:cNvPr id="5" name="TextBox 4"/>
-          <p:cNvSpPr txBox="1"/>
-          <p:nvPr/>
-        </p:nvSpPr>
-        <p:spPr>
-          <a:xfrm>
-            <a:off x="1371600" y="1828800"/>
-            <a:ext cx="7315200" cy="365760"/>
-          </a:xfrm>
-          <a:prstGeom prst="rect">
-            <a:avLst/>
-          </a:prstGeom>
-          <a:noFill/>
-        </p:spPr>
-        <p:txBody>
-          <a:bodyPr wrap="square">
-            <a:spAutoFit/>
-          </a:bodyPr>
-          <a:lstStyle/>
-          <a:p>
-            <a:pPr algn="l">
-              <a:defRPr sz="1400" b="0">
-                <a:solidFill>
-                  <a:srgbClr val="606060"/>
-                </a:solidFill>
-                <a:latin typeface="Calibri"/>
-              </a:defRPr>
-            </a:pPr>
-            <a:r>
-              <a:t>Los pesos se actualizan solo por el gradiente. No hay limite a su crecimiento.</a:t>
-            </a:r>
-          </a:p>
-        </p:txBody>
-      </p:sp>
-      <p:sp>
-        <p:nvSpPr>
-          <p:cNvPr id="6" name="Rounded Rectangle 5"/>
+              <a:defRPr sz="1700" b="1">
+                <a:solidFill>
+                  <a:srgbClr val="7B1FA2"/>
+                </a:solidFill>
+                <a:latin typeface="Calibri"/>
+              </a:defRPr>
+            </a:pPr>
+            <a:r>
+              <a:t>Efecto del Weight Decay en la actualizacion de pesos</a:t>
+            </a:r>
+          </a:p>
+        </p:txBody>
+      </p:sp>
+      <p:sp>
+        <p:nvSpPr>
+          <p:cNvPr id="5" name="Rounded Rectangle 4"/>
           <p:cNvSpPr/>
           <p:nvPr/>
         </p:nvSpPr>
         <p:spPr>
           <a:xfrm>
-            <a:off x="1371600" y="2286000"/>
-            <a:ext cx="7315200" cy="731520"/>
+            <a:off x="1097280" y="2011680"/>
+            <a:ext cx="9966960" cy="1920240"/>
           </a:xfrm>
           <a:prstGeom prst="roundRect">
             <a:avLst>
@@ -8299,10 +8865,12 @@
             </a:avLst>
           </a:prstGeom>
           <a:solidFill>
-            <a:srgbClr val="F4F4F6"/>
+            <a:srgbClr val="F5EEFC"/>
           </a:solidFill>
-          <a:ln>
-            <a:noFill/>
+          <a:ln w="12700">
+            <a:solidFill>
+              <a:srgbClr val="7B1FA2"/>
+            </a:solidFill>
           </a:ln>
         </p:spPr>
         <p:style>
@@ -8327,9 +8895,81 @@
           </a:p>
         </p:txBody>
       </p:sp>
+      <p:sp>
+        <p:nvSpPr>
+          <p:cNvPr id="6" name="TextBox 5"/>
+          <p:cNvSpPr txBox="1"/>
+          <p:nvPr/>
+        </p:nvSpPr>
+        <p:spPr>
+          <a:xfrm>
+            <a:off x="1463040" y="2148840"/>
+            <a:ext cx="3657600" cy="365760"/>
+          </a:xfrm>
+          <a:prstGeom prst="rect">
+            <a:avLst/>
+          </a:prstGeom>
+          <a:noFill/>
+        </p:spPr>
+        <p:txBody>
+          <a:bodyPr wrap="square">
+            <a:spAutoFit/>
+          </a:bodyPr>
+          <a:lstStyle/>
+          <a:p>
+            <a:pPr algn="l">
+              <a:defRPr sz="2200" b="1">
+                <a:solidFill>
+                  <a:srgbClr val="7B1FA2"/>
+                </a:solidFill>
+                <a:latin typeface="Calibri"/>
+              </a:defRPr>
+            </a:pPr>
+            <a:r>
+              <a:t>Sin Weight Decay</a:t>
+            </a:r>
+          </a:p>
+        </p:txBody>
+      </p:sp>
+      <p:sp>
+        <p:nvSpPr>
+          <p:cNvPr id="7" name="TextBox 6"/>
+          <p:cNvSpPr txBox="1"/>
+          <p:nvPr/>
+        </p:nvSpPr>
+        <p:spPr>
+          <a:xfrm>
+            <a:off x="1463040" y="2606040"/>
+            <a:ext cx="8229600" cy="457200"/>
+          </a:xfrm>
+          <a:prstGeom prst="rect">
+            <a:avLst/>
+          </a:prstGeom>
+          <a:noFill/>
+        </p:spPr>
+        <p:txBody>
+          <a:bodyPr wrap="square">
+            <a:spAutoFit/>
+          </a:bodyPr>
+          <a:lstStyle/>
+          <a:p>
+            <a:pPr algn="l">
+              <a:defRPr sz="1500" b="0">
+                <a:solidFill>
+                  <a:srgbClr val="2A2A2A"/>
+                </a:solidFill>
+                <a:latin typeface="Calibri"/>
+              </a:defRPr>
+            </a:pPr>
+            <a:r>
+              <a:t>Los pesos se actualizan solo por el gradiente de la perdida. No hay limite a su crecimiento.</a:t>
+            </a:r>
+          </a:p>
+        </p:txBody>
+      </p:sp>
       <p:pic>
         <p:nvPicPr>
-          <p:cNvPr id="7" name="Picture 6" descr="f_sin_decay.png"/>
+          <p:cNvPr id="8" name="Picture 7" descr="f_sin_decay.png"/>
           <p:cNvPicPr>
             <a:picLocks noChangeAspect="1"/>
           </p:cNvPicPr>
@@ -8343,8 +8983,8 @@
         </p:blipFill>
         <p:spPr>
           <a:xfrm>
-            <a:off x="2286000" y="2331720"/>
-            <a:ext cx="5029200" cy="667749"/>
+            <a:off x="2286000" y="3017520"/>
+            <a:ext cx="5486400" cy="728453"/>
           </a:xfrm>
           <a:prstGeom prst="rect">
             <a:avLst/>
@@ -8353,86 +8993,14 @@
       </p:pic>
       <p:sp>
         <p:nvSpPr>
-          <p:cNvPr id="8" name="TextBox 7"/>
-          <p:cNvSpPr txBox="1"/>
-          <p:nvPr/>
-        </p:nvSpPr>
-        <p:spPr>
-          <a:xfrm>
-            <a:off x="1097280" y="3200400"/>
-            <a:ext cx="9144000" cy="365760"/>
-          </a:xfrm>
-          <a:prstGeom prst="rect">
-            <a:avLst/>
-          </a:prstGeom>
-          <a:noFill/>
-        </p:spPr>
-        <p:txBody>
-          <a:bodyPr wrap="square">
-            <a:spAutoFit/>
-          </a:bodyPr>
-          <a:lstStyle/>
-          <a:p>
-            <a:pPr algn="l">
-              <a:defRPr sz="1900" b="1">
-                <a:solidFill>
-                  <a:srgbClr val="2A2A2A"/>
-                </a:solidFill>
-                <a:latin typeface="Calibri"/>
-              </a:defRPr>
-            </a:pPr>
-            <a:r>
-              <a:t>Con Weight Decay (L2)</a:t>
-            </a:r>
-          </a:p>
-        </p:txBody>
-      </p:sp>
-      <p:sp>
-        <p:nvSpPr>
-          <p:cNvPr id="9" name="TextBox 8"/>
-          <p:cNvSpPr txBox="1"/>
-          <p:nvPr/>
-        </p:nvSpPr>
-        <p:spPr>
-          <a:xfrm>
-            <a:off x="1371600" y="3566160"/>
-            <a:ext cx="7315200" cy="365760"/>
-          </a:xfrm>
-          <a:prstGeom prst="rect">
-            <a:avLst/>
-          </a:prstGeom>
-          <a:noFill/>
-        </p:spPr>
-        <p:txBody>
-          <a:bodyPr wrap="square">
-            <a:spAutoFit/>
-          </a:bodyPr>
-          <a:lstStyle/>
-          <a:p>
-            <a:pPr algn="l">
-              <a:defRPr sz="1400" b="0">
-                <a:solidFill>
-                  <a:srgbClr val="606060"/>
-                </a:solidFill>
-                <a:latin typeface="Calibri"/>
-              </a:defRPr>
-            </a:pPr>
-            <a:r>
-              <a:t>El factor (1 - eta*lambda) encoge los pesos en cada paso. Pesos grandes se penalizan mas.</a:t>
-            </a:r>
-          </a:p>
-        </p:txBody>
-      </p:sp>
-      <p:sp>
-        <p:nvSpPr>
-          <p:cNvPr id="10" name="Rounded Rectangle 9"/>
+          <p:cNvPr id="9" name="Rounded Rectangle 8"/>
           <p:cNvSpPr/>
           <p:nvPr/>
         </p:nvSpPr>
         <p:spPr>
           <a:xfrm>
-            <a:off x="1371600" y="3931920"/>
-            <a:ext cx="8686800" cy="822960"/>
+            <a:off x="1097280" y="4206240"/>
+            <a:ext cx="9966960" cy="2286000"/>
           </a:xfrm>
           <a:prstGeom prst="roundRect">
             <a:avLst>
@@ -8440,10 +9008,12 @@
             </a:avLst>
           </a:prstGeom>
           <a:solidFill>
-            <a:srgbClr val="F4F4F6"/>
+            <a:srgbClr val="EEF7F0"/>
           </a:solidFill>
-          <a:ln>
-            <a:noFill/>
+          <a:ln w="12700">
+            <a:solidFill>
+              <a:srgbClr val="1E8850"/>
+            </a:solidFill>
           </a:ln>
         </p:spPr>
         <p:style>
@@ -8468,9 +9038,81 @@
           </a:p>
         </p:txBody>
       </p:sp>
+      <p:sp>
+        <p:nvSpPr>
+          <p:cNvPr id="10" name="TextBox 9"/>
+          <p:cNvSpPr txBox="1"/>
+          <p:nvPr/>
+        </p:nvSpPr>
+        <p:spPr>
+          <a:xfrm>
+            <a:off x="1463040" y="4343400"/>
+            <a:ext cx="3657600" cy="365760"/>
+          </a:xfrm>
+          <a:prstGeom prst="rect">
+            <a:avLst/>
+          </a:prstGeom>
+          <a:noFill/>
+        </p:spPr>
+        <p:txBody>
+          <a:bodyPr wrap="square">
+            <a:spAutoFit/>
+          </a:bodyPr>
+          <a:lstStyle/>
+          <a:p>
+            <a:pPr algn="l">
+              <a:defRPr sz="2200" b="1">
+                <a:solidFill>
+                  <a:srgbClr val="1E8850"/>
+                </a:solidFill>
+                <a:latin typeface="Calibri"/>
+              </a:defRPr>
+            </a:pPr>
+            <a:r>
+              <a:t>Con Weight Decay (L2)</a:t>
+            </a:r>
+          </a:p>
+        </p:txBody>
+      </p:sp>
+      <p:sp>
+        <p:nvSpPr>
+          <p:cNvPr id="11" name="TextBox 10"/>
+          <p:cNvSpPr txBox="1"/>
+          <p:nvPr/>
+        </p:nvSpPr>
+        <p:spPr>
+          <a:xfrm>
+            <a:off x="1463040" y="4800600"/>
+            <a:ext cx="8229600" cy="457200"/>
+          </a:xfrm>
+          <a:prstGeom prst="rect">
+            <a:avLst/>
+          </a:prstGeom>
+          <a:noFill/>
+        </p:spPr>
+        <p:txBody>
+          <a:bodyPr wrap="square">
+            <a:spAutoFit/>
+          </a:bodyPr>
+          <a:lstStyle/>
+          <a:p>
+            <a:pPr algn="l">
+              <a:defRPr sz="1500" b="0">
+                <a:solidFill>
+                  <a:srgbClr val="2A2A2A"/>
+                </a:solidFill>
+                <a:latin typeface="Calibri"/>
+              </a:defRPr>
+            </a:pPr>
+            <a:r>
+              <a:t>El factor (1 - eta * lambda) encoge los pesos en cada paso. Pesos grandes se penalizan mas.</a:t>
+            </a:r>
+          </a:p>
+        </p:txBody>
+      </p:sp>
       <p:pic>
         <p:nvPicPr>
-          <p:cNvPr id="11" name="Picture 10" descr="f_con_decay.png"/>
+          <p:cNvPr id="12" name="Picture 11" descr="f_con_decay.png"/>
           <p:cNvPicPr>
             <a:picLocks noChangeAspect="1"/>
           </p:cNvPicPr>
@@ -8484,218 +9126,8 @@
         </p:blipFill>
         <p:spPr>
           <a:xfrm>
-            <a:off x="1828800" y="3977639"/>
+            <a:off x="1828800" y="5303520"/>
             <a:ext cx="6858000" cy="788406"/>
-          </a:xfrm>
-          <a:prstGeom prst="rect">
-            <a:avLst/>
-          </a:prstGeom>
-        </p:spPr>
-      </p:pic>
-      <p:sp>
-        <p:nvSpPr>
-          <p:cNvPr id="12" name="TextBox 11"/>
-          <p:cNvSpPr txBox="1"/>
-          <p:nvPr/>
-        </p:nvSpPr>
-        <p:spPr>
-          <a:xfrm>
-            <a:off x="1097280" y="4937760"/>
-            <a:ext cx="4572000" cy="365760"/>
-          </a:xfrm>
-          <a:prstGeom prst="rect">
-            <a:avLst/>
-          </a:prstGeom>
-          <a:noFill/>
-        </p:spPr>
-        <p:txBody>
-          <a:bodyPr wrap="square">
-            <a:spAutoFit/>
-          </a:bodyPr>
-          <a:lstStyle/>
-          <a:p>
-            <a:pPr algn="l">
-              <a:defRPr sz="1900" b="1">
-                <a:solidFill>
-                  <a:srgbClr val="2A2A2A"/>
-                </a:solidFill>
-                <a:latin typeface="Calibri"/>
-              </a:defRPr>
-            </a:pPr>
-            <a:r>
-              <a:t>Dropout</a:t>
-            </a:r>
-          </a:p>
-        </p:txBody>
-      </p:sp>
-      <p:sp>
-        <p:nvSpPr>
-          <p:cNvPr id="13" name="Rounded Rectangle 12"/>
-          <p:cNvSpPr/>
-          <p:nvPr/>
-        </p:nvSpPr>
-        <p:spPr>
-          <a:xfrm>
-            <a:off x="1371600" y="5303520"/>
-            <a:ext cx="4572000" cy="1188720"/>
-          </a:xfrm>
-          <a:prstGeom prst="roundRect">
-            <a:avLst>
-              <a:gd name="adj" fmla="val 4000"/>
-            </a:avLst>
-          </a:prstGeom>
-          <a:solidFill>
-            <a:srgbClr val="F4F4F6"/>
-          </a:solidFill>
-          <a:ln>
-            <a:noFill/>
-          </a:ln>
-        </p:spPr>
-        <p:style>
-          <a:lnRef idx="1">
-            <a:schemeClr val="accent1"/>
-          </a:lnRef>
-          <a:fillRef idx="3">
-            <a:schemeClr val="accent1"/>
-          </a:fillRef>
-          <a:effectRef idx="2">
-            <a:schemeClr val="accent1"/>
-          </a:effectRef>
-          <a:fontRef idx="minor">
-            <a:schemeClr val="lt1"/>
-          </a:fontRef>
-        </p:style>
-        <p:txBody>
-          <a:bodyPr rtlCol="0" anchor="ctr"/>
-          <a:lstStyle/>
-          <a:p>
-            <a:pPr algn="ctr"/>
-          </a:p>
-        </p:txBody>
-      </p:sp>
-      <p:pic>
-        <p:nvPicPr>
-          <p:cNvPr id="14" name="Picture 13" descr="f_dropout.png"/>
-          <p:cNvPicPr>
-            <a:picLocks noChangeAspect="1"/>
-          </p:cNvPicPr>
-          <p:nvPr/>
-        </p:nvPicPr>
-        <p:blipFill>
-          <a:blip r:embed="rId4"/>
-          <a:stretch>
-            <a:fillRect/>
-          </a:stretch>
-        </p:blipFill>
-        <p:spPr>
-          <a:xfrm>
-            <a:off x="1645920" y="5349240"/>
-            <a:ext cx="3657600" cy="470423"/>
-          </a:xfrm>
-          <a:prstGeom prst="rect">
-            <a:avLst/>
-          </a:prstGeom>
-        </p:spPr>
-      </p:pic>
-      <p:sp>
-        <p:nvSpPr>
-          <p:cNvPr id="15" name="TextBox 14"/>
-          <p:cNvSpPr txBox="1"/>
-          <p:nvPr/>
-        </p:nvSpPr>
-        <p:spPr>
-          <a:xfrm>
-            <a:off x="6400800" y="4937760"/>
-            <a:ext cx="4572000" cy="365760"/>
-          </a:xfrm>
-          <a:prstGeom prst="rect">
-            <a:avLst/>
-          </a:prstGeom>
-          <a:noFill/>
-        </p:spPr>
-        <p:txBody>
-          <a:bodyPr wrap="square">
-            <a:spAutoFit/>
-          </a:bodyPr>
-          <a:lstStyle/>
-          <a:p>
-            <a:pPr algn="l">
-              <a:defRPr sz="1900" b="1">
-                <a:solidFill>
-                  <a:srgbClr val="2A2A2A"/>
-                </a:solidFill>
-                <a:latin typeface="Calibri"/>
-              </a:defRPr>
-            </a:pPr>
-            <a:r>
-              <a:t>Loss total con L2</a:t>
-            </a:r>
-          </a:p>
-        </p:txBody>
-      </p:sp>
-      <p:sp>
-        <p:nvSpPr>
-          <p:cNvPr id="16" name="Rounded Rectangle 15"/>
-          <p:cNvSpPr/>
-          <p:nvPr/>
-        </p:nvSpPr>
-        <p:spPr>
-          <a:xfrm>
-            <a:off x="6400800" y="5303520"/>
-            <a:ext cx="5029200" cy="914400"/>
-          </a:xfrm>
-          <a:prstGeom prst="roundRect">
-            <a:avLst>
-              <a:gd name="adj" fmla="val 4000"/>
-            </a:avLst>
-          </a:prstGeom>
-          <a:solidFill>
-            <a:srgbClr val="F4F4F6"/>
-          </a:solidFill>
-          <a:ln>
-            <a:noFill/>
-          </a:ln>
-        </p:spPr>
-        <p:style>
-          <a:lnRef idx="1">
-            <a:schemeClr val="accent1"/>
-          </a:lnRef>
-          <a:fillRef idx="3">
-            <a:schemeClr val="accent1"/>
-          </a:fillRef>
-          <a:effectRef idx="2">
-            <a:schemeClr val="accent1"/>
-          </a:effectRef>
-          <a:fontRef idx="minor">
-            <a:schemeClr val="lt1"/>
-          </a:fontRef>
-        </p:style>
-        <p:txBody>
-          <a:bodyPr rtlCol="0" anchor="ctr"/>
-          <a:lstStyle/>
-          <a:p>
-            <a:pPr algn="ctr"/>
-          </a:p>
-        </p:txBody>
-      </p:sp>
-      <p:pic>
-        <p:nvPicPr>
-          <p:cNvPr id="17" name="Picture 16" descr="f_loss_total.png"/>
-          <p:cNvPicPr>
-            <a:picLocks noChangeAspect="1"/>
-          </p:cNvPicPr>
-          <p:nvPr/>
-        </p:nvPicPr>
-        <p:blipFill>
-          <a:blip r:embed="rId5"/>
-          <a:stretch>
-            <a:fillRect/>
-          </a:stretch>
-        </p:blipFill>
-        <p:spPr>
-          <a:xfrm>
-            <a:off x="6583680" y="5394960"/>
-            <a:ext cx="4572000" cy="655554"/>
           </a:xfrm>
           <a:prstGeom prst="rect">
             <a:avLst/>
@@ -8716,7 +9148,7 @@
     <p:bg>
       <p:bgPr>
         <a:solidFill>
-          <a:srgbClr val="14141E"/>
+          <a:srgbClr val="FBFBFB"/>
         </a:solidFill>
         <a:effectLst/>
       </p:bgPr>
@@ -8753,13 +9185,13 @@
             <a:pPr algn="l">
               <a:defRPr sz="4200" b="1">
                 <a:solidFill>
-                  <a:srgbClr val="FFFFFF"/>
-                </a:solidFill>
-                <a:latin typeface="Calibri"/>
-              </a:defRPr>
-            </a:pPr>
-            <a:r>
-              <a:t>Conclusiones</a:t>
+                  <a:srgbClr val="181818"/>
+                </a:solidFill>
+                <a:latin typeface="Calibri"/>
+              </a:defRPr>
+            </a:pPr>
+            <a:r>
+              <a:t>Bonus Matematico</a:t>
             </a:r>
           </a:p>
         </p:txBody>
@@ -8779,7 +9211,7 @@
             <a:avLst/>
           </a:prstGeom>
           <a:solidFill>
-            <a:srgbClr val="1A73E8"/>
+            <a:srgbClr val="7B1FA2"/>
           </a:solidFill>
           <a:ln>
             <a:noFill/>
@@ -8809,23 +9241,63 @@
       </p:sp>
       <p:sp>
         <p:nvSpPr>
-          <p:cNvPr id="4" name="Oval 3"/>
+          <p:cNvPr id="4" name="TextBox 3"/>
+          <p:cNvSpPr txBox="1"/>
+          <p:nvPr/>
+        </p:nvSpPr>
+        <p:spPr>
+          <a:xfrm>
+            <a:off x="1097280" y="1280160"/>
+            <a:ext cx="9144000" cy="365760"/>
+          </a:xfrm>
+          <a:prstGeom prst="rect">
+            <a:avLst/>
+          </a:prstGeom>
+          <a:noFill/>
+        </p:spPr>
+        <p:txBody>
+          <a:bodyPr wrap="square">
+            <a:spAutoFit/>
+          </a:bodyPr>
+          <a:lstStyle/>
+          <a:p>
+            <a:pPr algn="l">
+              <a:defRPr sz="1700" b="1">
+                <a:solidFill>
+                  <a:srgbClr val="7B1FA2"/>
+                </a:solidFill>
+                <a:latin typeface="Calibri"/>
+              </a:defRPr>
+            </a:pPr>
+            <a:r>
+              <a:t>Dropout y funcion de perdida regularizada</a:t>
+            </a:r>
+          </a:p>
+        </p:txBody>
+      </p:sp>
+      <p:sp>
+        <p:nvSpPr>
+          <p:cNvPr id="5" name="Rounded Rectangle 4"/>
           <p:cNvSpPr/>
           <p:nvPr/>
         </p:nvSpPr>
         <p:spPr>
           <a:xfrm>
-            <a:off x="1097280" y="1600200"/>
-            <a:ext cx="152400" cy="152400"/>
-          </a:xfrm>
-          <a:prstGeom prst="ellipse">
-            <a:avLst/>
+            <a:off x="1097280" y="2011680"/>
+            <a:ext cx="9966960" cy="2011680"/>
+          </a:xfrm>
+          <a:prstGeom prst="roundRect">
+            <a:avLst>
+              <a:gd name="adj" fmla="val 4000"/>
+            </a:avLst>
           </a:prstGeom>
           <a:solidFill>
-            <a:srgbClr val="1A73E8"/>
+            <a:srgbClr val="F5EEFC"/>
           </a:solidFill>
-          <a:ln>
-            <a:noFill/>
+          <a:ln w="12700">
+            <a:solidFill>
+              <a:srgbClr val="7B1FA2"/>
+            </a:solidFill>
           </a:ln>
         </p:spPr>
         <p:style>
@@ -8852,14 +9324,14 @@
       </p:sp>
       <p:sp>
         <p:nvSpPr>
-          <p:cNvPr id="5" name="TextBox 4"/>
+          <p:cNvPr id="6" name="TextBox 5"/>
           <p:cNvSpPr txBox="1"/>
           <p:nvPr/>
         </p:nvSpPr>
         <p:spPr>
           <a:xfrm>
-            <a:off x="1463040" y="1417320"/>
-            <a:ext cx="2743200" cy="365760"/>
+            <a:off x="1463040" y="2148840"/>
+            <a:ext cx="3657600" cy="365760"/>
           </a:xfrm>
           <a:prstGeom prst="rect">
             <a:avLst/>
@@ -8873,29 +9345,29 @@
           <a:lstStyle/>
           <a:p>
             <a:pPr algn="l">
-              <a:defRPr sz="2000" b="1">
-                <a:solidFill>
-                  <a:srgbClr val="1A73E8"/>
-                </a:solidFill>
-                <a:latin typeface="Calibri"/>
-              </a:defRPr>
-            </a:pPr>
-            <a:r>
-              <a:t>Diagnostico</a:t>
-            </a:r>
-          </a:p>
-        </p:txBody>
-      </p:sp>
-      <p:sp>
-        <p:nvSpPr>
-          <p:cNvPr id="6" name="TextBox 5"/>
+              <a:defRPr sz="2200" b="1">
+                <a:solidFill>
+                  <a:srgbClr val="7B1FA2"/>
+                </a:solidFill>
+                <a:latin typeface="Calibri"/>
+              </a:defRPr>
+            </a:pPr>
+            <a:r>
+              <a:t>Dropout</a:t>
+            </a:r>
+          </a:p>
+        </p:txBody>
+      </p:sp>
+      <p:sp>
+        <p:nvSpPr>
+          <p:cNvPr id="7" name="TextBox 6"/>
           <p:cNvSpPr txBox="1"/>
           <p:nvPr/>
         </p:nvSpPr>
         <p:spPr>
           <a:xfrm>
-            <a:off x="1463040" y="1783080"/>
-            <a:ext cx="9144000" cy="457200"/>
+            <a:off x="1463040" y="2606040"/>
+            <a:ext cx="8229600" cy="457200"/>
           </a:xfrm>
           <a:prstGeom prst="rect">
             <a:avLst/>
@@ -8909,38 +9381,66 @@
           <a:lstStyle/>
           <a:p>
             <a:pPr algn="l">
-              <a:defRPr sz="1600" b="0">
-                <a:solidFill>
-                  <a:srgbClr val="E8E8E8"/>
-                </a:solidFill>
-                <a:latin typeface="Calibri"/>
-              </a:defRPr>
-            </a:pPr>
-            <a:r>
-              <a:t>El modelo memorizaba el dataset. Train ~100%, Test ~65-75%. Overfitting violento por falta de regularizacion.</a:t>
-            </a:r>
-          </a:p>
-        </p:txBody>
-      </p:sp>
-      <p:sp>
-        <p:nvSpPr>
-          <p:cNvPr id="7" name="Oval 6"/>
+              <a:defRPr sz="1500" b="0">
+                <a:solidFill>
+                  <a:srgbClr val="2A2A2A"/>
+                </a:solidFill>
+                <a:latin typeface="Calibri"/>
+              </a:defRPr>
+            </a:pPr>
+            <a:r>
+              <a:t>En cada forward pass se anulan neuronas al azar. Equivale a entrenar un ensemble de sub-redes.</a:t>
+            </a:r>
+          </a:p>
+        </p:txBody>
+      </p:sp>
+      <p:pic>
+        <p:nvPicPr>
+          <p:cNvPr id="8" name="Picture 7" descr="f_dropout.png"/>
+          <p:cNvPicPr>
+            <a:picLocks noChangeAspect="1"/>
+          </p:cNvPicPr>
+          <p:nvPr/>
+        </p:nvPicPr>
+        <p:blipFill>
+          <a:blip r:embed="rId2"/>
+          <a:stretch>
+            <a:fillRect/>
+          </a:stretch>
+        </p:blipFill>
+        <p:spPr>
+          <a:xfrm>
+            <a:off x="1828800" y="3108960"/>
+            <a:ext cx="5943600" cy="764438"/>
+          </a:xfrm>
+          <a:prstGeom prst="rect">
+            <a:avLst/>
+          </a:prstGeom>
+        </p:spPr>
+      </p:pic>
+      <p:sp>
+        <p:nvSpPr>
+          <p:cNvPr id="9" name="Rounded Rectangle 8"/>
           <p:cNvSpPr/>
           <p:nvPr/>
         </p:nvSpPr>
         <p:spPr>
           <a:xfrm>
-            <a:off x="1097280" y="2651760"/>
-            <a:ext cx="152400" cy="152400"/>
-          </a:xfrm>
-          <a:prstGeom prst="ellipse">
-            <a:avLst/>
+            <a:off x="1097280" y="4297680"/>
+            <a:ext cx="9966960" cy="2103120"/>
+          </a:xfrm>
+          <a:prstGeom prst="roundRect">
+            <a:avLst>
+              <a:gd name="adj" fmla="val 4000"/>
+            </a:avLst>
           </a:prstGeom>
           <a:solidFill>
-            <a:srgbClr val="1A73E8"/>
+            <a:srgbClr val="EEF7F0"/>
           </a:solidFill>
-          <a:ln>
-            <a:noFill/>
+          <a:ln w="12700">
+            <a:solidFill>
+              <a:srgbClr val="1E8850"/>
+            </a:solidFill>
           </a:ln>
         </p:spPr>
         <p:style>
@@ -8967,14 +9467,14 @@
       </p:sp>
       <p:sp>
         <p:nvSpPr>
-          <p:cNvPr id="8" name="TextBox 7"/>
+          <p:cNvPr id="10" name="TextBox 9"/>
           <p:cNvSpPr txBox="1"/>
           <p:nvPr/>
         </p:nvSpPr>
         <p:spPr>
           <a:xfrm>
-            <a:off x="1463040" y="2468880"/>
-            <a:ext cx="2743200" cy="365760"/>
+            <a:off x="1463040" y="4434840"/>
+            <a:ext cx="4572000" cy="365760"/>
           </a:xfrm>
           <a:prstGeom prst="rect">
             <a:avLst/>
@@ -8988,29 +9488,29 @@
           <a:lstStyle/>
           <a:p>
             <a:pPr algn="l">
-              <a:defRPr sz="2000" b="1">
-                <a:solidFill>
-                  <a:srgbClr val="1A73E8"/>
-                </a:solidFill>
-                <a:latin typeface="Calibri"/>
-              </a:defRPr>
-            </a:pPr>
-            <a:r>
-              <a:t>Interruptor</a:t>
-            </a:r>
-          </a:p>
-        </p:txBody>
-      </p:sp>
-      <p:sp>
-        <p:nvSpPr>
-          <p:cNvPr id="9" name="TextBox 8"/>
+              <a:defRPr sz="2200" b="1">
+                <a:solidFill>
+                  <a:srgbClr val="1E8850"/>
+                </a:solidFill>
+                <a:latin typeface="Calibri"/>
+              </a:defRPr>
+            </a:pPr>
+            <a:r>
+              <a:t>Loss total con regularizacion L2</a:t>
+            </a:r>
+          </a:p>
+        </p:txBody>
+      </p:sp>
+      <p:sp>
+        <p:nvSpPr>
+          <p:cNvPr id="11" name="TextBox 10"/>
           <p:cNvSpPr txBox="1"/>
           <p:nvPr/>
         </p:nvSpPr>
         <p:spPr>
           <a:xfrm>
-            <a:off x="1463040" y="2834640"/>
-            <a:ext cx="9144000" cy="457200"/>
+            <a:off x="1463040" y="4892040"/>
+            <a:ext cx="8229600" cy="457200"/>
           </a:xfrm>
           <a:prstGeom prst="rect">
             <a:avLst/>
@@ -9024,285 +9524,43 @@
           <a:lstStyle/>
           <a:p>
             <a:pPr algn="l">
-              <a:defRPr sz="1600" b="0">
-                <a:solidFill>
-                  <a:srgbClr val="E8E8E8"/>
-                </a:solidFill>
-                <a:latin typeface="Calibri"/>
-              </a:defRPr>
-            </a:pPr>
-            <a:r>
-              <a:t>Activamos Weight Decay (L2=0.01), Dropout (p=0.3) y redujimos la red de ~19K a ~300 parametros.</a:t>
-            </a:r>
-          </a:p>
-        </p:txBody>
-      </p:sp>
-      <p:sp>
-        <p:nvSpPr>
-          <p:cNvPr id="10" name="Oval 9"/>
-          <p:cNvSpPr/>
-          <p:nvPr/>
-        </p:nvSpPr>
-        <p:spPr>
-          <a:xfrm>
-            <a:off x="1097280" y="3703320"/>
-            <a:ext cx="152400" cy="152400"/>
-          </a:xfrm>
-          <a:prstGeom prst="ellipse">
-            <a:avLst/>
-          </a:prstGeom>
-          <a:solidFill>
-            <a:srgbClr val="1A73E8"/>
-          </a:solidFill>
-          <a:ln>
-            <a:noFill/>
-          </a:ln>
-        </p:spPr>
-        <p:style>
-          <a:lnRef idx="1">
-            <a:schemeClr val="accent1"/>
-          </a:lnRef>
-          <a:fillRef idx="3">
-            <a:schemeClr val="accent1"/>
-          </a:fillRef>
-          <a:effectRef idx="2">
-            <a:schemeClr val="accent1"/>
-          </a:effectRef>
-          <a:fontRef idx="minor">
-            <a:schemeClr val="lt1"/>
-          </a:fontRef>
-        </p:style>
-        <p:txBody>
-          <a:bodyPr rtlCol="0" anchor="ctr"/>
-          <a:lstStyle/>
-          <a:p>
-            <a:pPr algn="ctr"/>
-          </a:p>
-        </p:txBody>
-      </p:sp>
-      <p:sp>
-        <p:nvSpPr>
-          <p:cNvPr id="11" name="TextBox 10"/>
-          <p:cNvSpPr txBox="1"/>
-          <p:nvPr/>
-        </p:nvSpPr>
-        <p:spPr>
-          <a:xfrm>
-            <a:off x="1463040" y="3520440"/>
-            <a:ext cx="2743200" cy="365760"/>
-          </a:xfrm>
-          <a:prstGeom prst="rect">
-            <a:avLst/>
-          </a:prstGeom>
-          <a:noFill/>
-        </p:spPr>
-        <p:txBody>
-          <a:bodyPr wrap="square">
-            <a:spAutoFit/>
-          </a:bodyPr>
-          <a:lstStyle/>
-          <a:p>
-            <a:pPr algn="l">
-              <a:defRPr sz="2000" b="1">
-                <a:solidFill>
-                  <a:srgbClr val="1A73E8"/>
-                </a:solidFill>
-                <a:latin typeface="Calibri"/>
-              </a:defRPr>
-            </a:pPr>
-            <a:r>
-              <a:t>Resultado</a:t>
-            </a:r>
-          </a:p>
-        </p:txBody>
-      </p:sp>
-      <p:sp>
-        <p:nvSpPr>
-          <p:cNvPr id="12" name="TextBox 11"/>
-          <p:cNvSpPr txBox="1"/>
-          <p:nvPr/>
-        </p:nvSpPr>
-        <p:spPr>
-          <a:xfrm>
-            <a:off x="1463040" y="3886200"/>
-            <a:ext cx="9144000" cy="457200"/>
-          </a:xfrm>
-          <a:prstGeom prst="rect">
-            <a:avLst/>
-          </a:prstGeom>
-          <a:noFill/>
-        </p:spPr>
-        <p:txBody>
-          <a:bodyPr wrap="square">
-            <a:spAutoFit/>
-          </a:bodyPr>
-          <a:lstStyle/>
-          <a:p>
-            <a:pPr algn="l">
-              <a:defRPr sz="1600" b="0">
-                <a:solidFill>
-                  <a:srgbClr val="E8E8E8"/>
-                </a:solidFill>
-                <a:latin typeface="Calibri"/>
-              </a:defRPr>
-            </a:pPr>
-            <a:r>
-              <a:t>La brecha train-test se redujo de ~30% a menos del 7%. El modelo ahora generaliza.</a:t>
-            </a:r>
-          </a:p>
-        </p:txBody>
-      </p:sp>
-      <p:sp>
-        <p:nvSpPr>
-          <p:cNvPr id="13" name="Oval 12"/>
-          <p:cNvSpPr/>
-          <p:nvPr/>
-        </p:nvSpPr>
-        <p:spPr>
-          <a:xfrm>
-            <a:off x="1097280" y="4754880"/>
-            <a:ext cx="152400" cy="152400"/>
-          </a:xfrm>
-          <a:prstGeom prst="ellipse">
-            <a:avLst/>
-          </a:prstGeom>
-          <a:solidFill>
-            <a:srgbClr val="1A73E8"/>
-          </a:solidFill>
-          <a:ln>
-            <a:noFill/>
-          </a:ln>
-        </p:spPr>
-        <p:style>
-          <a:lnRef idx="1">
-            <a:schemeClr val="accent1"/>
-          </a:lnRef>
-          <a:fillRef idx="3">
-            <a:schemeClr val="accent1"/>
-          </a:fillRef>
-          <a:effectRef idx="2">
-            <a:schemeClr val="accent1"/>
-          </a:effectRef>
-          <a:fontRef idx="minor">
-            <a:schemeClr val="lt1"/>
-          </a:fontRef>
-        </p:style>
-        <p:txBody>
-          <a:bodyPr rtlCol="0" anchor="ctr"/>
-          <a:lstStyle/>
-          <a:p>
-            <a:pPr algn="ctr"/>
-          </a:p>
-        </p:txBody>
-      </p:sp>
-      <p:sp>
-        <p:nvSpPr>
-          <p:cNvPr id="14" name="TextBox 13"/>
-          <p:cNvSpPr txBox="1"/>
-          <p:nvPr/>
-        </p:nvSpPr>
-        <p:spPr>
-          <a:xfrm>
-            <a:off x="1463040" y="4572000"/>
-            <a:ext cx="2743200" cy="365760"/>
-          </a:xfrm>
-          <a:prstGeom prst="rect">
-            <a:avLst/>
-          </a:prstGeom>
-          <a:noFill/>
-        </p:spPr>
-        <p:txBody>
-          <a:bodyPr wrap="square">
-            <a:spAutoFit/>
-          </a:bodyPr>
-          <a:lstStyle/>
-          <a:p>
-            <a:pPr algn="l">
-              <a:defRPr sz="2000" b="1">
-                <a:solidFill>
-                  <a:srgbClr val="1A73E8"/>
-                </a:solidFill>
-                <a:latin typeface="Calibri"/>
-              </a:defRPr>
-            </a:pPr>
-            <a:r>
-              <a:t>HealthTech</a:t>
-            </a:r>
-          </a:p>
-        </p:txBody>
-      </p:sp>
-      <p:sp>
-        <p:nvSpPr>
-          <p:cNvPr id="15" name="TextBox 14"/>
-          <p:cNvSpPr txBox="1"/>
-          <p:nvPr/>
-        </p:nvSpPr>
-        <p:spPr>
-          <a:xfrm>
-            <a:off x="1463040" y="4937759"/>
-            <a:ext cx="9144000" cy="457200"/>
-          </a:xfrm>
-          <a:prstGeom prst="rect">
-            <a:avLst/>
-          </a:prstGeom>
-          <a:noFill/>
-        </p:spPr>
-        <p:txBody>
-          <a:bodyPr wrap="square">
-            <a:spAutoFit/>
-          </a:bodyPr>
-          <a:lstStyle/>
-          <a:p>
-            <a:pPr algn="l">
-              <a:defRPr sz="1600" b="0">
-                <a:solidFill>
-                  <a:srgbClr val="E8E8E8"/>
-                </a:solidFill>
-                <a:latin typeface="Calibri"/>
-              </a:defRPr>
-            </a:pPr>
-            <a:r>
-              <a:t>En medicina, un modelo con overfitting da diagnosticos falsos en pacientes nuevos. La regularizacion es esencial.</a:t>
-            </a:r>
-          </a:p>
-        </p:txBody>
-      </p:sp>
-      <p:sp>
-        <p:nvSpPr>
-          <p:cNvPr id="16" name="TextBox 15"/>
-          <p:cNvSpPr txBox="1"/>
-          <p:nvPr/>
-        </p:nvSpPr>
-        <p:spPr>
-          <a:xfrm>
-            <a:off x="1097280" y="5943600"/>
-            <a:ext cx="9966960" cy="365760"/>
-          </a:xfrm>
-          <a:prstGeom prst="rect">
-            <a:avLst/>
-          </a:prstGeom>
-          <a:noFill/>
-        </p:spPr>
-        <p:txBody>
-          <a:bodyPr wrap="square">
-            <a:spAutoFit/>
-          </a:bodyPr>
-          <a:lstStyle/>
-          <a:p>
-            <a:pPr algn="ctr">
-              <a:defRPr sz="1300" b="0">
-                <a:solidFill>
-                  <a:srgbClr val="909090"/>
-                </a:solidFill>
-                <a:latin typeface="Calibri"/>
-              </a:defRPr>
-            </a:pPr>
-            <a:r>
-              <a:t>Grupo 7  |  La Memoria de Pez  |  Bloque 3: Problemas de Estrategia</a:t>
-            </a:r>
-          </a:p>
-        </p:txBody>
-      </p:sp>
+              <a:defRPr sz="1500" b="0">
+                <a:solidFill>
+                  <a:srgbClr val="2A2A2A"/>
+                </a:solidFill>
+                <a:latin typeface="Calibri"/>
+              </a:defRPr>
+            </a:pPr>
+            <a:r>
+              <a:t>El termino de regularizacion anade un gradiente 2*lambda*w que fluye por todas las capas, controlando la magnitud de cada peso.</a:t>
+            </a:r>
+          </a:p>
+        </p:txBody>
+      </p:sp>
+      <p:pic>
+        <p:nvPicPr>
+          <p:cNvPr id="12" name="Picture 11" descr="f_loss_total.png"/>
+          <p:cNvPicPr>
+            <a:picLocks noChangeAspect="1"/>
+          </p:cNvPicPr>
+          <p:nvPr/>
+        </p:nvPicPr>
+        <p:blipFill>
+          <a:blip r:embed="rId3"/>
+          <a:stretch>
+            <a:fillRect/>
+          </a:stretch>
+        </p:blipFill>
+        <p:spPr>
+          <a:xfrm>
+            <a:off x="2286000" y="5394960"/>
+            <a:ext cx="5486400" cy="786665"/>
+          </a:xfrm>
+          <a:prstGeom prst="rect">
+            <a:avLst/>
+          </a:prstGeom>
+        </p:spPr>
+      </p:pic>
     </p:spTree>
   </p:cSld>
   <p:clrMapOvr>

</xml_diff>